<commit_message>
UI: 更換 Favicon 與新增手機桌面圖示 (apple-touch-icon) 為 /uploads/髦.png
</commit_message>
<xml_diff>
--- a/uploads/簡報1.pptx
+++ b/uploads/簡報1.pptx
@@ -104,6 +104,11 @@
       </a:defRPr>
     </a:lvl9pPr>
   </p:defaultTextStyle>
+  <p:extLst>
+    <p:ext uri="{EFAFB233-063F-42B5-8137-9DF3F51BA10A}">
+      <p15:sldGuideLst xmlns:p15="http://schemas.microsoft.com/office/powerpoint/2012/main"/>
+    </p:ext>
+  </p:extLst>
 </p:presentation>
 </file>
 
@@ -254,7 +259,7 @@
           <a:p>
             <a:fld id="{15C307BF-59FF-3040-A16F-C43EEB4A0C58}" type="datetimeFigureOut">
               <a:rPr kumimoji="1" lang="zh-TW" altLang="en-US" smtClean="0"/>
-              <a:t>2026/3/25</a:t>
+              <a:t>2026/4/5</a:t>
             </a:fld>
             <a:endParaRPr kumimoji="1" lang="zh-TW" altLang="en-US"/>
           </a:p>
@@ -452,7 +457,7 @@
           <a:p>
             <a:fld id="{15C307BF-59FF-3040-A16F-C43EEB4A0C58}" type="datetimeFigureOut">
               <a:rPr kumimoji="1" lang="zh-TW" altLang="en-US" smtClean="0"/>
-              <a:t>2026/3/25</a:t>
+              <a:t>2026/4/5</a:t>
             </a:fld>
             <a:endParaRPr kumimoji="1" lang="zh-TW" altLang="en-US"/>
           </a:p>
@@ -660,7 +665,7 @@
           <a:p>
             <a:fld id="{15C307BF-59FF-3040-A16F-C43EEB4A0C58}" type="datetimeFigureOut">
               <a:rPr kumimoji="1" lang="zh-TW" altLang="en-US" smtClean="0"/>
-              <a:t>2026/3/25</a:t>
+              <a:t>2026/4/5</a:t>
             </a:fld>
             <a:endParaRPr kumimoji="1" lang="zh-TW" altLang="en-US"/>
           </a:p>
@@ -858,7 +863,7 @@
           <a:p>
             <a:fld id="{15C307BF-59FF-3040-A16F-C43EEB4A0C58}" type="datetimeFigureOut">
               <a:rPr kumimoji="1" lang="zh-TW" altLang="en-US" smtClean="0"/>
-              <a:t>2026/3/25</a:t>
+              <a:t>2026/4/5</a:t>
             </a:fld>
             <a:endParaRPr kumimoji="1" lang="zh-TW" altLang="en-US"/>
           </a:p>
@@ -1133,7 +1138,7 @@
           <a:p>
             <a:fld id="{15C307BF-59FF-3040-A16F-C43EEB4A0C58}" type="datetimeFigureOut">
               <a:rPr kumimoji="1" lang="zh-TW" altLang="en-US" smtClean="0"/>
-              <a:t>2026/3/25</a:t>
+              <a:t>2026/4/5</a:t>
             </a:fld>
             <a:endParaRPr kumimoji="1" lang="zh-TW" altLang="en-US"/>
           </a:p>
@@ -1398,7 +1403,7 @@
           <a:p>
             <a:fld id="{15C307BF-59FF-3040-A16F-C43EEB4A0C58}" type="datetimeFigureOut">
               <a:rPr kumimoji="1" lang="zh-TW" altLang="en-US" smtClean="0"/>
-              <a:t>2026/3/25</a:t>
+              <a:t>2026/4/5</a:t>
             </a:fld>
             <a:endParaRPr kumimoji="1" lang="zh-TW" altLang="en-US"/>
           </a:p>
@@ -1810,7 +1815,7 @@
           <a:p>
             <a:fld id="{15C307BF-59FF-3040-A16F-C43EEB4A0C58}" type="datetimeFigureOut">
               <a:rPr kumimoji="1" lang="zh-TW" altLang="en-US" smtClean="0"/>
-              <a:t>2026/3/25</a:t>
+              <a:t>2026/4/5</a:t>
             </a:fld>
             <a:endParaRPr kumimoji="1" lang="zh-TW" altLang="en-US"/>
           </a:p>
@@ -1951,7 +1956,7 @@
           <a:p>
             <a:fld id="{15C307BF-59FF-3040-A16F-C43EEB4A0C58}" type="datetimeFigureOut">
               <a:rPr kumimoji="1" lang="zh-TW" altLang="en-US" smtClean="0"/>
-              <a:t>2026/3/25</a:t>
+              <a:t>2026/4/5</a:t>
             </a:fld>
             <a:endParaRPr kumimoji="1" lang="zh-TW" altLang="en-US"/>
           </a:p>
@@ -2064,7 +2069,7 @@
           <a:p>
             <a:fld id="{15C307BF-59FF-3040-A16F-C43EEB4A0C58}" type="datetimeFigureOut">
               <a:rPr kumimoji="1" lang="zh-TW" altLang="en-US" smtClean="0"/>
-              <a:t>2026/3/25</a:t>
+              <a:t>2026/4/5</a:t>
             </a:fld>
             <a:endParaRPr kumimoji="1" lang="zh-TW" altLang="en-US"/>
           </a:p>
@@ -2375,7 +2380,7 @@
           <a:p>
             <a:fld id="{15C307BF-59FF-3040-A16F-C43EEB4A0C58}" type="datetimeFigureOut">
               <a:rPr kumimoji="1" lang="zh-TW" altLang="en-US" smtClean="0"/>
-              <a:t>2026/3/25</a:t>
+              <a:t>2026/4/5</a:t>
             </a:fld>
             <a:endParaRPr kumimoji="1" lang="zh-TW" altLang="en-US"/>
           </a:p>
@@ -2663,7 +2668,7 @@
           <a:p>
             <a:fld id="{15C307BF-59FF-3040-A16F-C43EEB4A0C58}" type="datetimeFigureOut">
               <a:rPr kumimoji="1" lang="zh-TW" altLang="en-US" smtClean="0"/>
-              <a:t>2026/3/25</a:t>
+              <a:t>2026/4/5</a:t>
             </a:fld>
             <a:endParaRPr kumimoji="1" lang="zh-TW" altLang="en-US"/>
           </a:p>
@@ -2904,7 +2909,7 @@
           <a:p>
             <a:fld id="{15C307BF-59FF-3040-A16F-C43EEB4A0C58}" type="datetimeFigureOut">
               <a:rPr kumimoji="1" lang="zh-TW" altLang="en-US" smtClean="0"/>
-              <a:t>2026/3/25</a:t>
+              <a:t>2026/4/5</a:t>
             </a:fld>
             <a:endParaRPr kumimoji="1" lang="zh-TW" altLang="en-US"/>
           </a:p>
@@ -3323,10 +3328,10 @@
       </p:grpSpPr>
       <p:sp>
         <p:nvSpPr>
-          <p:cNvPr id="6" name="文字方塊 5">
-            <a:extLst>
-              <a:ext uri="{FF2B5EF4-FFF2-40B4-BE49-F238E27FC236}">
-                <a16:creationId xmlns:a16="http://schemas.microsoft.com/office/drawing/2014/main" id="{710CDC27-5CF8-AC64-AEE6-71A0678A00D9}"/>
+          <p:cNvPr id="14" name="文字方塊 13">
+            <a:extLst>
+              <a:ext uri="{FF2B5EF4-FFF2-40B4-BE49-F238E27FC236}">
+                <a16:creationId xmlns:a16="http://schemas.microsoft.com/office/drawing/2014/main" id="{F05FE1B1-0EF6-34DA-31FC-0550E885FE7F}"/>
               </a:ext>
             </a:extLst>
           </p:cNvPr>
@@ -3335,27 +3340,80 @@
         </p:nvSpPr>
         <p:spPr>
           <a:xfrm>
-            <a:off x="4514598" y="2026037"/>
-            <a:ext cx="1536526" cy="1503218"/>
+            <a:off x="4711886" y="2344333"/>
+            <a:ext cx="1161222" cy="858129"/>
           </a:xfrm>
-          <a:prstGeom prst="rect">
+          <a:custGeom>
             <a:avLst/>
-          </a:prstGeom>
-          <a:noFill/>
+            <a:gdLst/>
+            <a:ahLst/>
+            <a:cxnLst/>
+            <a:rect l="l" t="t" r="r" b="b"/>
+            <a:pathLst>
+              <a:path w="1161222" h="858129">
+                <a:moveTo>
+                  <a:pt x="0" y="420086"/>
+                </a:moveTo>
+                <a:lnTo>
+                  <a:pt x="277518" y="858129"/>
+                </a:lnTo>
+                <a:lnTo>
+                  <a:pt x="0" y="858129"/>
+                </a:lnTo>
+                <a:close/>
+                <a:moveTo>
+                  <a:pt x="901661" y="0"/>
+                </a:moveTo>
+                <a:lnTo>
+                  <a:pt x="1161222" y="0"/>
+                </a:lnTo>
+                <a:lnTo>
+                  <a:pt x="1161222" y="858129"/>
+                </a:lnTo>
+                <a:lnTo>
+                  <a:pt x="674206" y="858129"/>
+                </a:lnTo>
+                <a:lnTo>
+                  <a:pt x="674206" y="357509"/>
+                </a:lnTo>
+                <a:close/>
+                <a:moveTo>
+                  <a:pt x="1089" y="0"/>
+                </a:moveTo>
+                <a:lnTo>
+                  <a:pt x="385805" y="0"/>
+                </a:lnTo>
+                <a:lnTo>
+                  <a:pt x="642101" y="408115"/>
+                </a:lnTo>
+                <a:lnTo>
+                  <a:pt x="359141" y="851599"/>
+                </a:lnTo>
+                <a:lnTo>
+                  <a:pt x="1089" y="287313"/>
+                </a:lnTo>
+                <a:close/>
+              </a:path>
+            </a:pathLst>
+          </a:custGeom>
+          <a:solidFill>
+            <a:schemeClr val="tx1"/>
+          </a:solidFill>
+          <a:ln>
+            <a:noFill/>
+          </a:ln>
+          <a:effectLst/>
         </p:spPr>
         <p:txBody>
-          <a:bodyPr wrap="square" rtlCol="0" anchor="ctr">
-            <a:spAutoFit/>
+          <a:bodyPr rot="0" spcFirstLastPara="0" vertOverflow="overflow" horzOverflow="overflow" vert="horz" wrap="square" lIns="91440" tIns="45720" rIns="91440" bIns="45720" numCol="1" spcCol="0" rtlCol="0" fromWordArt="0" anchor="t" anchorCtr="0" forceAA="0" compatLnSpc="1">
+            <a:prstTxWarp prst="textNoShape">
+              <a:avLst/>
+            </a:prstTxWarp>
+            <a:noAutofit/>
           </a:bodyPr>
           <a:lstStyle/>
           <a:p>
             <a:pPr algn="ctr"/>
-            <a:r>
-              <a:rPr kumimoji="1" lang="en-US" altLang="zh-TW" sz="8800" dirty="0">
-                <a:latin typeface="Braggadocio" pitchFamily="82" charset="0"/>
-              </a:rPr>
-              <a:t>M</a:t>
-            </a:r>
             <a:endParaRPr kumimoji="1" lang="zh-TW" altLang="en-US" sz="8800" dirty="0">
               <a:latin typeface="Braggadocio" pitchFamily="82" charset="0"/>
             </a:endParaRPr>
@@ -3364,10 +3422,10 @@
       </p:sp>
       <p:sp>
         <p:nvSpPr>
-          <p:cNvPr id="7" name="文字方塊 6">
-            <a:extLst>
-              <a:ext uri="{FF2B5EF4-FFF2-40B4-BE49-F238E27FC236}">
-                <a16:creationId xmlns:a16="http://schemas.microsoft.com/office/drawing/2014/main" id="{548445DA-D0AB-8CB1-45F6-0833F8D05A23}"/>
+          <p:cNvPr id="16" name="文字方塊 15">
+            <a:extLst>
+              <a:ext uri="{FF2B5EF4-FFF2-40B4-BE49-F238E27FC236}">
+                <a16:creationId xmlns:a16="http://schemas.microsoft.com/office/drawing/2014/main" id="{6311430E-0984-938E-492D-BF581A639F48}"/>
               </a:ext>
             </a:extLst>
           </p:cNvPr>
@@ -3376,27 +3434,136 @@
         </p:nvSpPr>
         <p:spPr>
           <a:xfrm>
-            <a:off x="6025026" y="2022858"/>
-            <a:ext cx="1536526" cy="1503218"/>
+            <a:off x="6274847" y="2335713"/>
+            <a:ext cx="1057289" cy="867923"/>
           </a:xfrm>
-          <a:prstGeom prst="rect">
+          <a:custGeom>
             <a:avLst/>
-          </a:prstGeom>
-          <a:noFill/>
+            <a:gdLst/>
+            <a:ahLst/>
+            <a:cxnLst/>
+            <a:rect l="l" t="t" r="r" b="b"/>
+            <a:pathLst>
+              <a:path w="1057289" h="867923">
+                <a:moveTo>
+                  <a:pt x="564831" y="0"/>
+                </a:moveTo>
+                <a:lnTo>
+                  <a:pt x="608363" y="0"/>
+                </a:lnTo>
+                <a:cubicBezTo>
+                  <a:pt x="670397" y="0"/>
+                  <a:pt x="728802" y="10883"/>
+                  <a:pt x="783580" y="32649"/>
+                </a:cubicBezTo>
+                <a:cubicBezTo>
+                  <a:pt x="839447" y="55503"/>
+                  <a:pt x="887514" y="86157"/>
+                  <a:pt x="927781" y="124611"/>
+                </a:cubicBezTo>
+                <a:cubicBezTo>
+                  <a:pt x="968411" y="163790"/>
+                  <a:pt x="1000153" y="209680"/>
+                  <a:pt x="1023008" y="262281"/>
+                </a:cubicBezTo>
+                <a:cubicBezTo>
+                  <a:pt x="1045862" y="314883"/>
+                  <a:pt x="1057289" y="371475"/>
+                  <a:pt x="1057289" y="432057"/>
+                </a:cubicBezTo>
+                <a:cubicBezTo>
+                  <a:pt x="1057289" y="493728"/>
+                  <a:pt x="1046225" y="550682"/>
+                  <a:pt x="1024096" y="602921"/>
+                </a:cubicBezTo>
+                <a:cubicBezTo>
+                  <a:pt x="1001241" y="656974"/>
+                  <a:pt x="969862" y="703589"/>
+                  <a:pt x="929958" y="742768"/>
+                </a:cubicBezTo>
+                <a:cubicBezTo>
+                  <a:pt x="888965" y="783398"/>
+                  <a:pt x="841261" y="814234"/>
+                  <a:pt x="786845" y="835274"/>
+                </a:cubicBezTo>
+                <a:cubicBezTo>
+                  <a:pt x="732430" y="857040"/>
+                  <a:pt x="674024" y="867923"/>
+                  <a:pt x="611628" y="867923"/>
+                </a:cubicBezTo>
+                <a:lnTo>
+                  <a:pt x="564831" y="867923"/>
+                </a:lnTo>
+                <a:close/>
+                <a:moveTo>
+                  <a:pt x="453280" y="0"/>
+                </a:moveTo>
+                <a:lnTo>
+                  <a:pt x="491370" y="0"/>
+                </a:lnTo>
+                <a:lnTo>
+                  <a:pt x="491370" y="867923"/>
+                </a:lnTo>
+                <a:lnTo>
+                  <a:pt x="425528" y="867923"/>
+                </a:lnTo>
+                <a:cubicBezTo>
+                  <a:pt x="348258" y="867923"/>
+                  <a:pt x="277156" y="848334"/>
+                  <a:pt x="212220" y="809155"/>
+                </a:cubicBezTo>
+                <a:cubicBezTo>
+                  <a:pt x="147284" y="770701"/>
+                  <a:pt x="95590" y="717737"/>
+                  <a:pt x="57137" y="650262"/>
+                </a:cubicBezTo>
+                <a:cubicBezTo>
+                  <a:pt x="19046" y="583150"/>
+                  <a:pt x="0" y="510778"/>
+                  <a:pt x="0" y="433145"/>
+                </a:cubicBezTo>
+                <a:cubicBezTo>
+                  <a:pt x="0" y="371837"/>
+                  <a:pt x="11246" y="314339"/>
+                  <a:pt x="33738" y="260649"/>
+                </a:cubicBezTo>
+                <a:cubicBezTo>
+                  <a:pt x="56592" y="206596"/>
+                  <a:pt x="87972" y="160525"/>
+                  <a:pt x="127876" y="122434"/>
+                </a:cubicBezTo>
+                <a:cubicBezTo>
+                  <a:pt x="169232" y="83255"/>
+                  <a:pt x="217662" y="53145"/>
+                  <a:pt x="273165" y="32105"/>
+                </a:cubicBezTo>
+                <a:cubicBezTo>
+                  <a:pt x="329757" y="10701"/>
+                  <a:pt x="389795" y="0"/>
+                  <a:pt x="453280" y="0"/>
+                </a:cubicBezTo>
+                <a:close/>
+              </a:path>
+            </a:pathLst>
+          </a:custGeom>
+          <a:solidFill>
+            <a:schemeClr val="tx1"/>
+          </a:solidFill>
+          <a:ln>
+            <a:noFill/>
+          </a:ln>
+          <a:effectLst/>
         </p:spPr>
         <p:txBody>
-          <a:bodyPr wrap="square" rtlCol="0" anchor="ctr">
-            <a:spAutoFit/>
+          <a:bodyPr rot="0" spcFirstLastPara="0" vertOverflow="overflow" horzOverflow="overflow" vert="horz" wrap="square" lIns="91440" tIns="45720" rIns="91440" bIns="45720" numCol="1" spcCol="0" rtlCol="0" fromWordArt="0" anchor="t" anchorCtr="0" forceAA="0" compatLnSpc="1">
+            <a:prstTxWarp prst="textNoShape">
+              <a:avLst/>
+            </a:prstTxWarp>
+            <a:noAutofit/>
           </a:bodyPr>
           <a:lstStyle/>
           <a:p>
             <a:pPr algn="ctr"/>
-            <a:r>
-              <a:rPr kumimoji="1" lang="en-US" altLang="zh-TW" sz="8800" dirty="0">
-                <a:latin typeface="Braggadocio" pitchFamily="82" charset="0"/>
-              </a:rPr>
-              <a:t>O</a:t>
-            </a:r>
             <a:endParaRPr kumimoji="1" lang="zh-TW" altLang="en-US" sz="8800" dirty="0">
               <a:latin typeface="Braggadocio" pitchFamily="82" charset="0"/>
             </a:endParaRPr>
@@ -3405,10 +3572,10 @@
       </p:sp>
       <p:sp>
         <p:nvSpPr>
-          <p:cNvPr id="8" name="文字方塊 7">
-            <a:extLst>
-              <a:ext uri="{FF2B5EF4-FFF2-40B4-BE49-F238E27FC236}">
-                <a16:creationId xmlns:a16="http://schemas.microsoft.com/office/drawing/2014/main" id="{AB581F87-F2CC-975C-237F-3BCE171B2E5F}"/>
+          <p:cNvPr id="18" name="文字方塊 17">
+            <a:extLst>
+              <a:ext uri="{FF2B5EF4-FFF2-40B4-BE49-F238E27FC236}">
+                <a16:creationId xmlns:a16="http://schemas.microsoft.com/office/drawing/2014/main" id="{449CD96A-9E9C-EAFD-3F95-00C66C8008A8}"/>
               </a:ext>
             </a:extLst>
           </p:cNvPr>
@@ -3417,36 +3584,136 @@
         </p:nvSpPr>
         <p:spPr>
           <a:xfrm>
-            <a:off x="4598625" y="3429000"/>
-            <a:ext cx="1342374" cy="1446550"/>
+            <a:off x="4760975" y="3718962"/>
+            <a:ext cx="1066540" cy="858129"/>
           </a:xfrm>
-          <a:prstGeom prst="rect">
+          <a:custGeom>
             <a:avLst/>
-          </a:prstGeom>
-          <a:noFill/>
+            <a:gdLst/>
+            <a:ahLst/>
+            <a:cxnLst/>
+            <a:rect l="l" t="t" r="r" b="b"/>
+            <a:pathLst>
+              <a:path w="1066540" h="858129">
+                <a:moveTo>
+                  <a:pt x="563742" y="0"/>
+                </a:moveTo>
+                <a:lnTo>
+                  <a:pt x="701957" y="0"/>
+                </a:lnTo>
+                <a:cubicBezTo>
+                  <a:pt x="747303" y="0"/>
+                  <a:pt x="783761" y="544"/>
+                  <a:pt x="811332" y="1633"/>
+                </a:cubicBezTo>
+                <a:cubicBezTo>
+                  <a:pt x="840353" y="2721"/>
+                  <a:pt x="863752" y="5079"/>
+                  <a:pt x="881528" y="8707"/>
+                </a:cubicBezTo>
+                <a:cubicBezTo>
+                  <a:pt x="900029" y="12334"/>
+                  <a:pt x="916716" y="17232"/>
+                  <a:pt x="931590" y="23399"/>
+                </a:cubicBezTo>
+                <a:cubicBezTo>
+                  <a:pt x="962788" y="36821"/>
+                  <a:pt x="988363" y="54234"/>
+                  <a:pt x="1008315" y="75637"/>
+                </a:cubicBezTo>
+                <a:cubicBezTo>
+                  <a:pt x="1026091" y="94501"/>
+                  <a:pt x="1039876" y="116268"/>
+                  <a:pt x="1049671" y="140936"/>
+                </a:cubicBezTo>
+                <a:cubicBezTo>
+                  <a:pt x="1059103" y="165967"/>
+                  <a:pt x="1063819" y="191723"/>
+                  <a:pt x="1063819" y="218205"/>
+                </a:cubicBezTo>
+                <a:cubicBezTo>
+                  <a:pt x="1063819" y="281327"/>
+                  <a:pt x="1042778" y="333385"/>
+                  <a:pt x="1000697" y="374377"/>
+                </a:cubicBezTo>
+                <a:cubicBezTo>
+                  <a:pt x="988000" y="387074"/>
+                  <a:pt x="975666" y="397050"/>
+                  <a:pt x="963695" y="404306"/>
+                </a:cubicBezTo>
+                <a:cubicBezTo>
+                  <a:pt x="952812" y="410836"/>
+                  <a:pt x="933948" y="420268"/>
+                  <a:pt x="907103" y="432602"/>
+                </a:cubicBezTo>
+                <a:cubicBezTo>
+                  <a:pt x="929957" y="440220"/>
+                  <a:pt x="947189" y="447294"/>
+                  <a:pt x="958797" y="453824"/>
+                </a:cubicBezTo>
+                <a:cubicBezTo>
+                  <a:pt x="971494" y="461079"/>
+                  <a:pt x="983103" y="469967"/>
+                  <a:pt x="993623" y="480487"/>
+                </a:cubicBezTo>
+                <a:cubicBezTo>
+                  <a:pt x="1042234" y="524019"/>
+                  <a:pt x="1066540" y="584239"/>
+                  <a:pt x="1066540" y="661146"/>
+                </a:cubicBezTo>
+                <a:lnTo>
+                  <a:pt x="1066540" y="858129"/>
+                </a:lnTo>
+                <a:lnTo>
+                  <a:pt x="563742" y="858129"/>
+                </a:lnTo>
+                <a:close/>
+                <a:moveTo>
+                  <a:pt x="0" y="0"/>
+                </a:moveTo>
+                <a:lnTo>
+                  <a:pt x="490282" y="0"/>
+                </a:lnTo>
+                <a:lnTo>
+                  <a:pt x="490282" y="858129"/>
+                </a:lnTo>
+                <a:lnTo>
+                  <a:pt x="0" y="858129"/>
+                </a:lnTo>
+                <a:close/>
+              </a:path>
+            </a:pathLst>
+          </a:custGeom>
+          <a:solidFill>
+            <a:schemeClr val="tx1"/>
+          </a:solidFill>
+          <a:ln>
+            <a:noFill/>
+          </a:ln>
+          <a:effectLst/>
         </p:spPr>
         <p:txBody>
-          <a:bodyPr wrap="square" rtlCol="0" anchor="ctr">
-            <a:spAutoFit/>
+          <a:bodyPr rot="0" spcFirstLastPara="0" vertOverflow="overflow" horzOverflow="overflow" vert="horz" wrap="square" lIns="91440" tIns="45720" rIns="91440" bIns="45720" numCol="1" spcCol="0" rtlCol="0" fromWordArt="0" anchor="t" anchorCtr="0" forceAA="0" compatLnSpc="1">
+            <a:prstTxWarp prst="textNoShape">
+              <a:avLst/>
+            </a:prstTxWarp>
+            <a:noAutofit/>
           </a:bodyPr>
           <a:lstStyle/>
           <a:p>
             <a:pPr algn="ctr"/>
-            <a:r>
-              <a:rPr kumimoji="1" lang="en-US" altLang="zh-TW" sz="8800" dirty="0">
-                <a:latin typeface="Braggadocio" pitchFamily="82" charset="0"/>
-              </a:rPr>
-              <a:t>R</a:t>
-            </a:r>
-          </a:p>
-        </p:txBody>
-      </p:sp>
-      <p:sp>
-        <p:nvSpPr>
-          <p:cNvPr id="9" name="文字方塊 8">
-            <a:extLst>
-              <a:ext uri="{FF2B5EF4-FFF2-40B4-BE49-F238E27FC236}">
-                <a16:creationId xmlns:a16="http://schemas.microsoft.com/office/drawing/2014/main" id="{18E4D598-AA64-6C24-9D2F-C4A2D91213F5}"/>
+            <a:endParaRPr kumimoji="1" lang="en-US" altLang="zh-TW" sz="8800" dirty="0">
+              <a:latin typeface="Braggadocio" pitchFamily="82" charset="0"/>
+            </a:endParaRPr>
+          </a:p>
+        </p:txBody>
+      </p:sp>
+      <p:sp>
+        <p:nvSpPr>
+          <p:cNvPr id="20" name="文字方塊 19">
+            <a:extLst>
+              <a:ext uri="{FF2B5EF4-FFF2-40B4-BE49-F238E27FC236}">
+                <a16:creationId xmlns:a16="http://schemas.microsoft.com/office/drawing/2014/main" id="{5415A45D-3B0D-F7A4-AFF1-12534F653B37}"/>
               </a:ext>
             </a:extLst>
           </p:cNvPr>
@@ -3455,27 +3722,86 @@
         </p:nvSpPr>
         <p:spPr>
           <a:xfrm>
-            <a:off x="6096000" y="3429000"/>
-            <a:ext cx="1342374" cy="1446550"/>
+            <a:off x="6330063" y="3718962"/>
+            <a:ext cx="902749" cy="858129"/>
           </a:xfrm>
-          <a:prstGeom prst="rect">
+          <a:custGeom>
             <a:avLst/>
-          </a:prstGeom>
-          <a:noFill/>
+            <a:gdLst/>
+            <a:ahLst/>
+            <a:cxnLst/>
+            <a:rect l="l" t="t" r="r" b="b"/>
+            <a:pathLst>
+              <a:path w="902749" h="858129">
+                <a:moveTo>
+                  <a:pt x="494091" y="434778"/>
+                </a:moveTo>
+                <a:lnTo>
+                  <a:pt x="494091" y="840172"/>
+                </a:lnTo>
+                <a:lnTo>
+                  <a:pt x="812420" y="580611"/>
+                </a:lnTo>
+                <a:close/>
+                <a:moveTo>
+                  <a:pt x="496267" y="19046"/>
+                </a:moveTo>
+                <a:lnTo>
+                  <a:pt x="496267" y="424439"/>
+                </a:lnTo>
+                <a:lnTo>
+                  <a:pt x="811332" y="255208"/>
+                </a:lnTo>
+                <a:close/>
+                <a:moveTo>
+                  <a:pt x="0" y="0"/>
+                </a:moveTo>
+                <a:lnTo>
+                  <a:pt x="900573" y="0"/>
+                </a:lnTo>
+                <a:lnTo>
+                  <a:pt x="900573" y="323227"/>
+                </a:lnTo>
+                <a:lnTo>
+                  <a:pt x="814597" y="258473"/>
+                </a:lnTo>
+                <a:lnTo>
+                  <a:pt x="814597" y="578435"/>
+                </a:lnTo>
+                <a:lnTo>
+                  <a:pt x="902749" y="507151"/>
+                </a:lnTo>
+                <a:lnTo>
+                  <a:pt x="902749" y="858129"/>
+                </a:lnTo>
+                <a:lnTo>
+                  <a:pt x="0" y="858129"/>
+                </a:lnTo>
+                <a:close/>
+              </a:path>
+            </a:pathLst>
+          </a:custGeom>
+          <a:solidFill>
+            <a:schemeClr val="tx1"/>
+          </a:solidFill>
+          <a:ln>
+            <a:noFill/>
+          </a:ln>
+          <a:effectLst/>
         </p:spPr>
         <p:txBody>
-          <a:bodyPr wrap="square" rtlCol="0" anchor="ctr">
-            <a:spAutoFit/>
+          <a:bodyPr rot="0" spcFirstLastPara="0" vertOverflow="overflow" horzOverflow="overflow" vert="horz" wrap="square" lIns="91440" tIns="45720" rIns="91440" bIns="45720" numCol="1" spcCol="0" rtlCol="0" fromWordArt="0" anchor="t" anchorCtr="0" forceAA="0" compatLnSpc="1">
+            <a:prstTxWarp prst="textNoShape">
+              <a:avLst/>
+            </a:prstTxWarp>
+            <a:noAutofit/>
           </a:bodyPr>
           <a:lstStyle/>
           <a:p>
             <a:pPr algn="ctr"/>
-            <a:r>
-              <a:rPr kumimoji="1" lang="en-US" altLang="zh-TW" sz="8800" dirty="0">
-                <a:latin typeface="Braggadocio" pitchFamily="82" charset="0"/>
-              </a:rPr>
-              <a:t>E</a:t>
-            </a:r>
+            <a:endParaRPr kumimoji="1" lang="en-US" altLang="zh-TW" sz="8800" dirty="0">
+              <a:latin typeface="Braggadocio" pitchFamily="82" charset="0"/>
+            </a:endParaRPr>
           </a:p>
         </p:txBody>
       </p:sp>
@@ -3489,476 +3815,6 @@
   <p:clrMapOvr>
     <a:masterClrMapping/>
   </p:clrMapOvr>
-  <p:timing>
-    <p:tnLst>
-      <p:par>
-        <p:cTn id="1" dur="indefinite" restart="never" nodeType="tmRoot">
-          <p:childTnLst>
-            <p:seq concurrent="1" nextAc="seek">
-              <p:cTn id="2" dur="indefinite" nodeType="mainSeq">
-                <p:childTnLst>
-                  <p:par>
-                    <p:cTn id="3" fill="hold">
-                      <p:stCondLst>
-                        <p:cond delay="indefinite"/>
-                      </p:stCondLst>
-                      <p:childTnLst>
-                        <p:par>
-                          <p:cTn id="4" fill="hold">
-                            <p:stCondLst>
-                              <p:cond delay="0"/>
-                            </p:stCondLst>
-                            <p:childTnLst>
-                              <p:par>
-                                <p:cTn id="5" presetID="2" presetClass="entr" presetSubtype="8" fill="hold" grpId="0" nodeType="clickEffect">
-                                  <p:stCondLst>
-                                    <p:cond delay="0"/>
-                                  </p:stCondLst>
-                                  <p:childTnLst>
-                                    <p:set>
-                                      <p:cBhvr>
-                                        <p:cTn id="6" dur="1" fill="hold">
-                                          <p:stCondLst>
-                                            <p:cond delay="0"/>
-                                          </p:stCondLst>
-                                        </p:cTn>
-                                        <p:tgtEl>
-                                          <p:spTgt spid="6"/>
-                                        </p:tgtEl>
-                                        <p:attrNameLst>
-                                          <p:attrName>style.visibility</p:attrName>
-                                        </p:attrNameLst>
-                                      </p:cBhvr>
-                                      <p:to>
-                                        <p:strVal val="visible"/>
-                                      </p:to>
-                                    </p:set>
-                                    <p:anim calcmode="lin" valueType="num">
-                                      <p:cBhvr additive="base">
-                                        <p:cTn id="7" dur="500" fill="hold"/>
-                                        <p:tgtEl>
-                                          <p:spTgt spid="6"/>
-                                        </p:tgtEl>
-                                        <p:attrNameLst>
-                                          <p:attrName>ppt_x</p:attrName>
-                                        </p:attrNameLst>
-                                      </p:cBhvr>
-                                      <p:tavLst>
-                                        <p:tav tm="0">
-                                          <p:val>
-                                            <p:strVal val="0-#ppt_w/2"/>
-                                          </p:val>
-                                        </p:tav>
-                                        <p:tav tm="100000">
-                                          <p:val>
-                                            <p:strVal val="#ppt_x"/>
-                                          </p:val>
-                                        </p:tav>
-                                      </p:tavLst>
-                                    </p:anim>
-                                    <p:anim calcmode="lin" valueType="num">
-                                      <p:cBhvr additive="base">
-                                        <p:cTn id="8" dur="500" fill="hold"/>
-                                        <p:tgtEl>
-                                          <p:spTgt spid="6"/>
-                                        </p:tgtEl>
-                                        <p:attrNameLst>
-                                          <p:attrName>ppt_y</p:attrName>
-                                        </p:attrNameLst>
-                                      </p:cBhvr>
-                                      <p:tavLst>
-                                        <p:tav tm="0">
-                                          <p:val>
-                                            <p:strVal val="#ppt_y"/>
-                                          </p:val>
-                                        </p:tav>
-                                        <p:tav tm="100000">
-                                          <p:val>
-                                            <p:strVal val="#ppt_y"/>
-                                          </p:val>
-                                        </p:tav>
-                                      </p:tavLst>
-                                    </p:anim>
-                                  </p:childTnLst>
-                                </p:cTn>
-                              </p:par>
-                            </p:childTnLst>
-                          </p:cTn>
-                        </p:par>
-                        <p:par>
-                          <p:cTn id="9" fill="hold">
-                            <p:stCondLst>
-                              <p:cond delay="500"/>
-                            </p:stCondLst>
-                            <p:childTnLst>
-                              <p:par>
-                                <p:cTn id="10" presetID="2" presetClass="entr" presetSubtype="1" fill="hold" grpId="0" nodeType="afterEffect">
-                                  <p:stCondLst>
-                                    <p:cond delay="0"/>
-                                  </p:stCondLst>
-                                  <p:childTnLst>
-                                    <p:set>
-                                      <p:cBhvr>
-                                        <p:cTn id="11" dur="1" fill="hold">
-                                          <p:stCondLst>
-                                            <p:cond delay="0"/>
-                                          </p:stCondLst>
-                                        </p:cTn>
-                                        <p:tgtEl>
-                                          <p:spTgt spid="7"/>
-                                        </p:tgtEl>
-                                        <p:attrNameLst>
-                                          <p:attrName>style.visibility</p:attrName>
-                                        </p:attrNameLst>
-                                      </p:cBhvr>
-                                      <p:to>
-                                        <p:strVal val="visible"/>
-                                      </p:to>
-                                    </p:set>
-                                    <p:anim calcmode="lin" valueType="num">
-                                      <p:cBhvr additive="base">
-                                        <p:cTn id="12" dur="500" fill="hold"/>
-                                        <p:tgtEl>
-                                          <p:spTgt spid="7"/>
-                                        </p:tgtEl>
-                                        <p:attrNameLst>
-                                          <p:attrName>ppt_x</p:attrName>
-                                        </p:attrNameLst>
-                                      </p:cBhvr>
-                                      <p:tavLst>
-                                        <p:tav tm="0">
-                                          <p:val>
-                                            <p:strVal val="#ppt_x"/>
-                                          </p:val>
-                                        </p:tav>
-                                        <p:tav tm="100000">
-                                          <p:val>
-                                            <p:strVal val="#ppt_x"/>
-                                          </p:val>
-                                        </p:tav>
-                                      </p:tavLst>
-                                    </p:anim>
-                                    <p:anim calcmode="lin" valueType="num">
-                                      <p:cBhvr additive="base">
-                                        <p:cTn id="13" dur="500" fill="hold"/>
-                                        <p:tgtEl>
-                                          <p:spTgt spid="7"/>
-                                        </p:tgtEl>
-                                        <p:attrNameLst>
-                                          <p:attrName>ppt_y</p:attrName>
-                                        </p:attrNameLst>
-                                      </p:cBhvr>
-                                      <p:tavLst>
-                                        <p:tav tm="0">
-                                          <p:val>
-                                            <p:strVal val="0-#ppt_h/2"/>
-                                          </p:val>
-                                        </p:tav>
-                                        <p:tav tm="100000">
-                                          <p:val>
-                                            <p:strVal val="#ppt_y"/>
-                                          </p:val>
-                                        </p:tav>
-                                      </p:tavLst>
-                                    </p:anim>
-                                  </p:childTnLst>
-                                </p:cTn>
-                              </p:par>
-                            </p:childTnLst>
-                          </p:cTn>
-                        </p:par>
-                        <p:par>
-                          <p:cTn id="14" fill="hold">
-                            <p:stCondLst>
-                              <p:cond delay="1000"/>
-                            </p:stCondLst>
-                            <p:childTnLst>
-                              <p:par>
-                                <p:cTn id="15" presetID="2" presetClass="entr" presetSubtype="4" fill="hold" grpId="0" nodeType="afterEffect">
-                                  <p:stCondLst>
-                                    <p:cond delay="0"/>
-                                  </p:stCondLst>
-                                  <p:childTnLst>
-                                    <p:set>
-                                      <p:cBhvr>
-                                        <p:cTn id="16" dur="1" fill="hold">
-                                          <p:stCondLst>
-                                            <p:cond delay="0"/>
-                                          </p:stCondLst>
-                                        </p:cTn>
-                                        <p:tgtEl>
-                                          <p:spTgt spid="8"/>
-                                        </p:tgtEl>
-                                        <p:attrNameLst>
-                                          <p:attrName>style.visibility</p:attrName>
-                                        </p:attrNameLst>
-                                      </p:cBhvr>
-                                      <p:to>
-                                        <p:strVal val="visible"/>
-                                      </p:to>
-                                    </p:set>
-                                    <p:anim calcmode="lin" valueType="num">
-                                      <p:cBhvr additive="base">
-                                        <p:cTn id="17" dur="500" fill="hold"/>
-                                        <p:tgtEl>
-                                          <p:spTgt spid="8"/>
-                                        </p:tgtEl>
-                                        <p:attrNameLst>
-                                          <p:attrName>ppt_x</p:attrName>
-                                        </p:attrNameLst>
-                                      </p:cBhvr>
-                                      <p:tavLst>
-                                        <p:tav tm="0">
-                                          <p:val>
-                                            <p:strVal val="#ppt_x"/>
-                                          </p:val>
-                                        </p:tav>
-                                        <p:tav tm="100000">
-                                          <p:val>
-                                            <p:strVal val="#ppt_x"/>
-                                          </p:val>
-                                        </p:tav>
-                                      </p:tavLst>
-                                    </p:anim>
-                                    <p:anim calcmode="lin" valueType="num">
-                                      <p:cBhvr additive="base">
-                                        <p:cTn id="18" dur="500" fill="hold"/>
-                                        <p:tgtEl>
-                                          <p:spTgt spid="8"/>
-                                        </p:tgtEl>
-                                        <p:attrNameLst>
-                                          <p:attrName>ppt_y</p:attrName>
-                                        </p:attrNameLst>
-                                      </p:cBhvr>
-                                      <p:tavLst>
-                                        <p:tav tm="0">
-                                          <p:val>
-                                            <p:strVal val="1+#ppt_h/2"/>
-                                          </p:val>
-                                        </p:tav>
-                                        <p:tav tm="100000">
-                                          <p:val>
-                                            <p:strVal val="#ppt_y"/>
-                                          </p:val>
-                                        </p:tav>
-                                      </p:tavLst>
-                                    </p:anim>
-                                  </p:childTnLst>
-                                </p:cTn>
-                              </p:par>
-                            </p:childTnLst>
-                          </p:cTn>
-                        </p:par>
-                        <p:par>
-                          <p:cTn id="19" fill="hold">
-                            <p:stCondLst>
-                              <p:cond delay="1500"/>
-                            </p:stCondLst>
-                            <p:childTnLst>
-                              <p:par>
-                                <p:cTn id="20" presetID="2" presetClass="entr" presetSubtype="2" fill="hold" grpId="0" nodeType="afterEffect">
-                                  <p:stCondLst>
-                                    <p:cond delay="0"/>
-                                  </p:stCondLst>
-                                  <p:childTnLst>
-                                    <p:set>
-                                      <p:cBhvr>
-                                        <p:cTn id="21" dur="1" fill="hold">
-                                          <p:stCondLst>
-                                            <p:cond delay="0"/>
-                                          </p:stCondLst>
-                                        </p:cTn>
-                                        <p:tgtEl>
-                                          <p:spTgt spid="9"/>
-                                        </p:tgtEl>
-                                        <p:attrNameLst>
-                                          <p:attrName>style.visibility</p:attrName>
-                                        </p:attrNameLst>
-                                      </p:cBhvr>
-                                      <p:to>
-                                        <p:strVal val="visible"/>
-                                      </p:to>
-                                    </p:set>
-                                    <p:anim calcmode="lin" valueType="num">
-                                      <p:cBhvr additive="base">
-                                        <p:cTn id="22" dur="500" fill="hold"/>
-                                        <p:tgtEl>
-                                          <p:spTgt spid="9"/>
-                                        </p:tgtEl>
-                                        <p:attrNameLst>
-                                          <p:attrName>ppt_x</p:attrName>
-                                        </p:attrNameLst>
-                                      </p:cBhvr>
-                                      <p:tavLst>
-                                        <p:tav tm="0">
-                                          <p:val>
-                                            <p:strVal val="1+#ppt_w/2"/>
-                                          </p:val>
-                                        </p:tav>
-                                        <p:tav tm="100000">
-                                          <p:val>
-                                            <p:strVal val="#ppt_x"/>
-                                          </p:val>
-                                        </p:tav>
-                                      </p:tavLst>
-                                    </p:anim>
-                                    <p:anim calcmode="lin" valueType="num">
-                                      <p:cBhvr additive="base">
-                                        <p:cTn id="23" dur="500" fill="hold"/>
-                                        <p:tgtEl>
-                                          <p:spTgt spid="9"/>
-                                        </p:tgtEl>
-                                        <p:attrNameLst>
-                                          <p:attrName>ppt_y</p:attrName>
-                                        </p:attrNameLst>
-                                      </p:cBhvr>
-                                      <p:tavLst>
-                                        <p:tav tm="0">
-                                          <p:val>
-                                            <p:strVal val="#ppt_y"/>
-                                          </p:val>
-                                        </p:tav>
-                                        <p:tav tm="100000">
-                                          <p:val>
-                                            <p:strVal val="#ppt_y"/>
-                                          </p:val>
-                                        </p:tav>
-                                      </p:tavLst>
-                                    </p:anim>
-                                  </p:childTnLst>
-                                </p:cTn>
-                              </p:par>
-                            </p:childTnLst>
-                          </p:cTn>
-                        </p:par>
-                        <p:par>
-                          <p:cTn id="24" fill="hold">
-                            <p:stCondLst>
-                              <p:cond delay="2000"/>
-                            </p:stCondLst>
-                            <p:childTnLst>
-                              <p:par>
-                                <p:cTn id="25" presetID="0" presetClass="path" presetSubtype="0" accel="50000" decel="50000" fill="hold" grpId="1" nodeType="afterEffect">
-                                  <p:stCondLst>
-                                    <p:cond delay="0"/>
-                                  </p:stCondLst>
-                                  <p:childTnLst>
-                                    <p:animMotion origin="layout" path="M 0 0 L 0 -0.13125 " pathEditMode="relative" ptsTypes="AA">
-                                      <p:cBhvr>
-                                        <p:cTn id="26" dur="2000" fill="hold"/>
-                                        <p:tgtEl>
-                                          <p:spTgt spid="7"/>
-                                        </p:tgtEl>
-                                        <p:attrNameLst>
-                                          <p:attrName>ppt_x</p:attrName>
-                                          <p:attrName>ppt_y</p:attrName>
-                                        </p:attrNameLst>
-                                      </p:cBhvr>
-                                    </p:animMotion>
-                                  </p:childTnLst>
-                                </p:cTn>
-                              </p:par>
-                              <p:par>
-                                <p:cTn id="27" presetID="0" presetClass="path" presetSubtype="0" accel="50000" decel="50000" fill="hold" grpId="1" nodeType="withEffect">
-                                  <p:stCondLst>
-                                    <p:cond delay="0"/>
-                                  </p:stCondLst>
-                                  <p:childTnLst>
-                                    <p:animMotion origin="layout" path="M 0 0 L 0 -0.13125 " pathEditMode="relative" ptsTypes="AA">
-                                      <p:cBhvr>
-                                        <p:cTn id="28" dur="2000" fill="hold"/>
-                                        <p:tgtEl>
-                                          <p:spTgt spid="6"/>
-                                        </p:tgtEl>
-                                        <p:attrNameLst>
-                                          <p:attrName>ppt_x</p:attrName>
-                                          <p:attrName>ppt_y</p:attrName>
-                                        </p:attrNameLst>
-                                      </p:cBhvr>
-                                    </p:animMotion>
-                                  </p:childTnLst>
-                                </p:cTn>
-                              </p:par>
-                              <p:par>
-                                <p:cTn id="29" presetID="0" presetClass="path" presetSubtype="0" accel="50000" decel="50000" fill="hold" grpId="1" nodeType="withEffect">
-                                  <p:stCondLst>
-                                    <p:cond delay="0"/>
-                                  </p:stCondLst>
-                                  <p:childTnLst>
-                                    <p:animMotion origin="layout" path="M 0 0 L 0 0.13148 " pathEditMode="relative" ptsTypes="AA">
-                                      <p:cBhvr>
-                                        <p:cTn id="30" dur="2000" fill="hold"/>
-                                        <p:tgtEl>
-                                          <p:spTgt spid="8"/>
-                                        </p:tgtEl>
-                                        <p:attrNameLst>
-                                          <p:attrName>ppt_x</p:attrName>
-                                          <p:attrName>ppt_y</p:attrName>
-                                        </p:attrNameLst>
-                                      </p:cBhvr>
-                                    </p:animMotion>
-                                  </p:childTnLst>
-                                </p:cTn>
-                              </p:par>
-                              <p:par>
-                                <p:cTn id="31" presetID="0" presetClass="path" presetSubtype="0" accel="50000" decel="50000" fill="hold" grpId="1" nodeType="withEffect">
-                                  <p:stCondLst>
-                                    <p:cond delay="0"/>
-                                  </p:stCondLst>
-                                  <p:childTnLst>
-                                    <p:animMotion origin="layout" path="M 0 0 L 0 0.13148 " pathEditMode="relative" ptsTypes="AA">
-                                      <p:cBhvr>
-                                        <p:cTn id="32" dur="2000" fill="hold"/>
-                                        <p:tgtEl>
-                                          <p:spTgt spid="9"/>
-                                        </p:tgtEl>
-                                        <p:attrNameLst>
-                                          <p:attrName>ppt_x</p:attrName>
-                                          <p:attrName>ppt_y</p:attrName>
-                                        </p:attrNameLst>
-                                      </p:cBhvr>
-                                    </p:animMotion>
-                                  </p:childTnLst>
-                                </p:cTn>
-                              </p:par>
-                            </p:childTnLst>
-                          </p:cTn>
-                        </p:par>
-                      </p:childTnLst>
-                    </p:cTn>
-                  </p:par>
-                </p:childTnLst>
-              </p:cTn>
-              <p:prevCondLst>
-                <p:cond evt="onPrev" delay="0">
-                  <p:tgtEl>
-                    <p:sldTgt/>
-                  </p:tgtEl>
-                </p:cond>
-              </p:prevCondLst>
-              <p:nextCondLst>
-                <p:cond evt="onNext" delay="0">
-                  <p:tgtEl>
-                    <p:sldTgt/>
-                  </p:tgtEl>
-                </p:cond>
-              </p:nextCondLst>
-            </p:seq>
-          </p:childTnLst>
-        </p:cTn>
-      </p:par>
-    </p:tnLst>
-    <p:bldLst>
-      <p:bldP spid="6" grpId="0"/>
-      <p:bldP spid="6" grpId="1"/>
-      <p:bldP spid="7" grpId="0"/>
-      <p:bldP spid="7" grpId="1"/>
-      <p:bldP spid="8" grpId="0"/>
-      <p:bldP spid="8" grpId="1"/>
-      <p:bldP spid="9" grpId="0"/>
-      <p:bldP spid="9" grpId="1"/>
-    </p:bldLst>
-  </p:timing>
 </p:sld>
 </file>
 

</xml_diff>